<commit_message>
YYT: update assignment 2
</commit_message>
<xml_diff>
--- a/tutorial/T04/tut04.pptx
+++ b/tutorial/T04/tut04.pptx
@@ -141,30 +141,6 @@
 
 <file path=ppt/changesInfos/changesInfo1.xml><?xml version="1.0" encoding="utf-8"?>
 <pc:chgInfo xmlns:a="http://schemas.openxmlformats.org/drawingml/2006/main" xmlns:r="http://schemas.openxmlformats.org/officeDocument/2006/relationships" xmlns:ac="http://schemas.microsoft.com/office/drawing/2013/main/command" xmlns:pc="http://schemas.microsoft.com/office/powerpoint/2013/main/command">
-  <pc:docChgLst>
-    <pc:chgData name="Qingyu Song" userId="O4NG2utMRSC9bShTQouuMd1Uq3x00QhxVtEheGSGOoU=" providerId="None" clId="Web-{1A9491C6-FD31-4FA7-98FA-39E25D0B6578}"/>
-    <pc:docChg chg="modSld">
-      <pc:chgData name="Qingyu Song" userId="O4NG2utMRSC9bShTQouuMd1Uq3x00QhxVtEheGSGOoU=" providerId="None" clId="Web-{1A9491C6-FD31-4FA7-98FA-39E25D0B6578}" dt="2022-01-09T11:29:04.756" v="11" actId="20577"/>
-      <pc:docMkLst>
-        <pc:docMk/>
-      </pc:docMkLst>
-      <pc:sldChg chg="modSp">
-        <pc:chgData name="Qingyu Song" userId="O4NG2utMRSC9bShTQouuMd1Uq3x00QhxVtEheGSGOoU=" providerId="None" clId="Web-{1A9491C6-FD31-4FA7-98FA-39E25D0B6578}" dt="2022-01-09T11:29:04.756" v="11" actId="20577"/>
-        <pc:sldMkLst>
-          <pc:docMk/>
-          <pc:sldMk cId="1947847713" sldId="257"/>
-        </pc:sldMkLst>
-        <pc:spChg chg="mod">
-          <ac:chgData name="Qingyu Song" userId="O4NG2utMRSC9bShTQouuMd1Uq3x00QhxVtEheGSGOoU=" providerId="None" clId="Web-{1A9491C6-FD31-4FA7-98FA-39E25D0B6578}" dt="2022-01-09T11:29:04.756" v="11" actId="20577"/>
-          <ac:spMkLst>
-            <pc:docMk/>
-            <pc:sldMk cId="1947847713" sldId="257"/>
-            <ac:spMk id="3" creationId="{8F20472D-613F-3748-9CBD-88055CDB4B08}"/>
-          </ac:spMkLst>
-        </pc:spChg>
-      </pc:sldChg>
-    </pc:docChg>
-  </pc:docChgLst>
   <pc:docChgLst>
     <pc:chgData name="YANG, Yitao" userId="88e7822c-0337-4812-90b9-cac454a86cb3" providerId="ADAL" clId="{99F41875-7439-487D-9ECA-8FAFAEEE8A21}"/>
     <pc:docChg chg="undo custSel addSld modSld sldOrd">
@@ -979,6 +955,30 @@
     </pc:docChg>
   </pc:docChgLst>
   <pc:docChgLst>
+    <pc:chgData name="Qingyu Song" userId="O4NG2utMRSC9bShTQouuMd1Uq3x00QhxVtEheGSGOoU=" providerId="None" clId="Web-{1A9491C6-FD31-4FA7-98FA-39E25D0B6578}"/>
+    <pc:docChg chg="modSld">
+      <pc:chgData name="Qingyu Song" userId="O4NG2utMRSC9bShTQouuMd1Uq3x00QhxVtEheGSGOoU=" providerId="None" clId="Web-{1A9491C6-FD31-4FA7-98FA-39E25D0B6578}" dt="2022-01-09T11:29:04.756" v="11" actId="20577"/>
+      <pc:docMkLst>
+        <pc:docMk/>
+      </pc:docMkLst>
+      <pc:sldChg chg="modSp">
+        <pc:chgData name="Qingyu Song" userId="O4NG2utMRSC9bShTQouuMd1Uq3x00QhxVtEheGSGOoU=" providerId="None" clId="Web-{1A9491C6-FD31-4FA7-98FA-39E25D0B6578}" dt="2022-01-09T11:29:04.756" v="11" actId="20577"/>
+        <pc:sldMkLst>
+          <pc:docMk/>
+          <pc:sldMk cId="1947847713" sldId="257"/>
+        </pc:sldMkLst>
+        <pc:spChg chg="mod">
+          <ac:chgData name="Qingyu Song" userId="O4NG2utMRSC9bShTQouuMd1Uq3x00QhxVtEheGSGOoU=" providerId="None" clId="Web-{1A9491C6-FD31-4FA7-98FA-39E25D0B6578}" dt="2022-01-09T11:29:04.756" v="11" actId="20577"/>
+          <ac:spMkLst>
+            <pc:docMk/>
+            <pc:sldMk cId="1947847713" sldId="257"/>
+            <ac:spMk id="3" creationId="{8F20472D-613F-3748-9CBD-88055CDB4B08}"/>
+          </ac:spMkLst>
+        </pc:spChg>
+      </pc:sldChg>
+    </pc:docChg>
+  </pc:docChgLst>
+  <pc:docChgLst>
     <pc:chgData name="YANG, Yitao" userId="88e7822c-0337-4812-90b9-cac454a86cb3" providerId="ADAL" clId="{DEA34803-EBC2-B646-AD91-C98E90D4BE64}"/>
     <pc:docChg chg="modSld">
       <pc:chgData name="YANG, Yitao" userId="88e7822c-0337-4812-90b9-cac454a86cb3" providerId="ADAL" clId="{DEA34803-EBC2-B646-AD91-C98E90D4BE64}" dt="2025-02-02T15:16:09.759" v="2" actId="20577"/>
@@ -1087,7 +1087,7 @@
           <a:p>
             <a:fld id="{62FBE78F-E554-4806-A855-B19721C91D19}" type="datetimeFigureOut">
               <a:rPr lang="zh-CN" altLang="en-US" smtClean="0"/>
-              <a:t>2025/2/2</a:t>
+              <a:t>2025/2/5</a:t>
             </a:fld>
             <a:endParaRPr lang="zh-CN" altLang="en-US"/>
           </a:p>
@@ -1373,7 +1373,7 @@
       </p:grpSpPr>
       <p:sp>
         <p:nvSpPr>
-          <p:cNvPr id="2" name="幻灯片图像占位符 1"/>
+          <p:cNvPr id="2" name="Slide Image Placeholder 1"/>
           <p:cNvSpPr>
             <a:spLocks noGrp="1" noRot="1" noChangeAspect="1"/>
           </p:cNvSpPr>
@@ -1385,7 +1385,7 @@
       </p:sp>
       <p:sp>
         <p:nvSpPr>
-          <p:cNvPr id="3" name="备注占位符 2"/>
+          <p:cNvPr id="3" name="Notes Placeholder 2"/>
           <p:cNvSpPr>
             <a:spLocks noGrp="1"/>
           </p:cNvSpPr>
@@ -1399,16 +1399,24 @@
           <a:lstStyle/>
           <a:p>
             <a:r>
-              <a:rPr lang="en-US" altLang="zh-CN" dirty="0"/>
-              <a:t>Less CPU/DRAM/context switching/ not need to using lock for sync</a:t>
-            </a:r>
-            <a:endParaRPr lang="zh-CN" altLang="en-US" dirty="0"/>
-          </a:p>
-        </p:txBody>
-      </p:sp>
-      <p:sp>
-        <p:nvSpPr>
-          <p:cNvPr id="4" name="灯片编号占位符 3"/>
+              <a:rPr lang="en-HK" dirty="0"/>
+              <a:t>Hello everyone! Welcome to Tutorial 4 of CSCI 4430. I'm YANG </a:t>
+            </a:r>
+            <a:r>
+              <a:rPr lang="en-HK" dirty="0" err="1"/>
+              <a:t>Yitao</a:t>
+            </a:r>
+            <a:r>
+              <a:rPr lang="en-HK" dirty="0"/>
+              <a:t>, and today we'll be discussing an important concept in network programming - the select() function. </a:t>
+            </a:r>
+            <a:endParaRPr lang="en-US" dirty="0"/>
+          </a:p>
+        </p:txBody>
+      </p:sp>
+      <p:sp>
+        <p:nvSpPr>
+          <p:cNvPr id="4" name="Slide Number Placeholder 3"/>
           <p:cNvSpPr>
             <a:spLocks noGrp="1"/>
           </p:cNvSpPr>
@@ -1423,7 +1431,7 @@
           <a:p>
             <a:fld id="{54149050-F688-4072-B68F-BF1043D39F0B}" type="slidenum">
               <a:rPr lang="zh-CN" altLang="en-US" smtClean="0"/>
-              <a:t>4</a:t>
+              <a:t>1</a:t>
             </a:fld>
             <a:endParaRPr lang="zh-CN" altLang="en-US"/>
           </a:p>
@@ -1432,7 +1440,584 @@
     </p:spTree>
     <p:extLst>
       <p:ext uri="{BB962C8B-B14F-4D97-AF65-F5344CB8AC3E}">
-        <p14:creationId xmlns:p14="http://schemas.microsoft.com/office/powerpoint/2010/main" val="2384694073"/>
+        <p14:creationId xmlns:p14="http://schemas.microsoft.com/office/powerpoint/2010/main" val="3179458723"/>
+      </p:ext>
+    </p:extLst>
+  </p:cSld>
+  <p:clrMapOvr>
+    <a:masterClrMapping/>
+  </p:clrMapOvr>
+</p:notes>
+</file>
+
+<file path=ppt/notesSlides/notesSlide10.xml><?xml version="1.0" encoding="utf-8"?>
+<p:notes xmlns:a="http://schemas.openxmlformats.org/drawingml/2006/main" xmlns:r="http://schemas.openxmlformats.org/officeDocument/2006/relationships" xmlns:p="http://schemas.openxmlformats.org/presentationml/2006/main">
+  <p:cSld>
+    <p:spTree>
+      <p:nvGrpSpPr>
+        <p:cNvPr id="1" name=""/>
+        <p:cNvGrpSpPr/>
+        <p:nvPr/>
+      </p:nvGrpSpPr>
+      <p:grpSpPr>
+        <a:xfrm>
+          <a:off x="0" y="0"/>
+          <a:ext cx="0" cy="0"/>
+          <a:chOff x="0" y="0"/>
+          <a:chExt cx="0" cy="0"/>
+        </a:xfrm>
+      </p:grpSpPr>
+      <p:sp>
+        <p:nvSpPr>
+          <p:cNvPr id="2" name="Slide Image Placeholder 1"/>
+          <p:cNvSpPr>
+            <a:spLocks noGrp="1" noRot="1" noChangeAspect="1"/>
+          </p:cNvSpPr>
+          <p:nvPr>
+            <p:ph type="sldImg"/>
+          </p:nvPr>
+        </p:nvSpPr>
+        <p:spPr/>
+      </p:sp>
+      <p:sp>
+        <p:nvSpPr>
+          <p:cNvPr id="3" name="Notes Placeholder 2"/>
+          <p:cNvSpPr>
+            <a:spLocks noGrp="1"/>
+          </p:cNvSpPr>
+          <p:nvPr>
+            <p:ph type="body" idx="1"/>
+          </p:nvPr>
+        </p:nvSpPr>
+        <p:spPr/>
+        <p:txBody>
+          <a:bodyPr/>
+          <a:lstStyle/>
+          <a:p>
+            <a:r>
+              <a:rPr lang="en-HK" dirty="0"/>
+              <a:t>Let's break down the implementation into three main steps:</a:t>
+            </a:r>
+          </a:p>
+          <a:p>
+            <a:endParaRPr lang="en-HK" dirty="0"/>
+          </a:p>
+          <a:p>
+            <a:r>
+              <a:rPr lang="en-HK" dirty="0"/>
+              <a:t>Step 1: We initialize the </a:t>
+            </a:r>
+            <a:r>
+              <a:rPr lang="en-HK" dirty="0" err="1"/>
+              <a:t>fd_set</a:t>
+            </a:r>
+            <a:r>
+              <a:rPr lang="en-HK" dirty="0"/>
+              <a:t> using FD_ZERO and add our sockets using FD_SET.</a:t>
+            </a:r>
+            <a:endParaRPr lang="en-US" dirty="0"/>
+          </a:p>
+        </p:txBody>
+      </p:sp>
+      <p:sp>
+        <p:nvSpPr>
+          <p:cNvPr id="4" name="Slide Number Placeholder 3"/>
+          <p:cNvSpPr>
+            <a:spLocks noGrp="1"/>
+          </p:cNvSpPr>
+          <p:nvPr>
+            <p:ph type="sldNum" sz="quarter" idx="5"/>
+          </p:nvPr>
+        </p:nvSpPr>
+        <p:spPr/>
+        <p:txBody>
+          <a:bodyPr/>
+          <a:lstStyle/>
+          <a:p>
+            <a:fld id="{54149050-F688-4072-B68F-BF1043D39F0B}" type="slidenum">
+              <a:rPr lang="zh-CN" altLang="en-US" smtClean="0"/>
+              <a:t>10</a:t>
+            </a:fld>
+            <a:endParaRPr lang="zh-CN" altLang="en-US"/>
+          </a:p>
+        </p:txBody>
+      </p:sp>
+    </p:spTree>
+    <p:extLst>
+      <p:ext uri="{BB962C8B-B14F-4D97-AF65-F5344CB8AC3E}">
+        <p14:creationId xmlns:p14="http://schemas.microsoft.com/office/powerpoint/2010/main" val="1144708551"/>
+      </p:ext>
+    </p:extLst>
+  </p:cSld>
+  <p:clrMapOvr>
+    <a:masterClrMapping/>
+  </p:clrMapOvr>
+</p:notes>
+</file>
+
+<file path=ppt/notesSlides/notesSlide11.xml><?xml version="1.0" encoding="utf-8"?>
+<p:notes xmlns:a="http://schemas.openxmlformats.org/drawingml/2006/main" xmlns:r="http://schemas.openxmlformats.org/officeDocument/2006/relationships" xmlns:p="http://schemas.openxmlformats.org/presentationml/2006/main">
+  <p:cSld>
+    <p:spTree>
+      <p:nvGrpSpPr>
+        <p:cNvPr id="1" name=""/>
+        <p:cNvGrpSpPr/>
+        <p:nvPr/>
+      </p:nvGrpSpPr>
+      <p:grpSpPr>
+        <a:xfrm>
+          <a:off x="0" y="0"/>
+          <a:ext cx="0" cy="0"/>
+          <a:chOff x="0" y="0"/>
+          <a:chExt cx="0" cy="0"/>
+        </a:xfrm>
+      </p:grpSpPr>
+      <p:sp>
+        <p:nvSpPr>
+          <p:cNvPr id="2" name="Slide Image Placeholder 1"/>
+          <p:cNvSpPr>
+            <a:spLocks noGrp="1" noRot="1" noChangeAspect="1"/>
+          </p:cNvSpPr>
+          <p:nvPr>
+            <p:ph type="sldImg"/>
+          </p:nvPr>
+        </p:nvSpPr>
+        <p:spPr/>
+      </p:sp>
+      <p:sp>
+        <p:nvSpPr>
+          <p:cNvPr id="3" name="Notes Placeholder 2"/>
+          <p:cNvSpPr>
+            <a:spLocks noGrp="1"/>
+          </p:cNvSpPr>
+          <p:nvPr>
+            <p:ph type="body" idx="1"/>
+          </p:nvPr>
+        </p:nvSpPr>
+        <p:spPr/>
+        <p:txBody>
+          <a:bodyPr/>
+          <a:lstStyle/>
+          <a:p>
+            <a:r>
+              <a:rPr lang="en-HK" dirty="0"/>
+              <a:t>Step 2: We call select() with appropriate parameters, including our </a:t>
+            </a:r>
+            <a:r>
+              <a:rPr lang="en-HK" dirty="0" err="1"/>
+              <a:t>fd_set</a:t>
+            </a:r>
+            <a:r>
+              <a:rPr lang="en-HK" dirty="0"/>
+              <a:t> and timeout values.</a:t>
+            </a:r>
+            <a:endParaRPr lang="en-US" dirty="0"/>
+          </a:p>
+        </p:txBody>
+      </p:sp>
+      <p:sp>
+        <p:nvSpPr>
+          <p:cNvPr id="4" name="Slide Number Placeholder 3"/>
+          <p:cNvSpPr>
+            <a:spLocks noGrp="1"/>
+          </p:cNvSpPr>
+          <p:nvPr>
+            <p:ph type="sldNum" sz="quarter" idx="5"/>
+          </p:nvPr>
+        </p:nvSpPr>
+        <p:spPr/>
+        <p:txBody>
+          <a:bodyPr/>
+          <a:lstStyle/>
+          <a:p>
+            <a:fld id="{54149050-F688-4072-B68F-BF1043D39F0B}" type="slidenum">
+              <a:rPr lang="zh-CN" altLang="en-US" smtClean="0"/>
+              <a:t>11</a:t>
+            </a:fld>
+            <a:endParaRPr lang="zh-CN" altLang="en-US"/>
+          </a:p>
+        </p:txBody>
+      </p:sp>
+    </p:spTree>
+    <p:extLst>
+      <p:ext uri="{BB962C8B-B14F-4D97-AF65-F5344CB8AC3E}">
+        <p14:creationId xmlns:p14="http://schemas.microsoft.com/office/powerpoint/2010/main" val="154322123"/>
+      </p:ext>
+    </p:extLst>
+  </p:cSld>
+  <p:clrMapOvr>
+    <a:masterClrMapping/>
+  </p:clrMapOvr>
+</p:notes>
+</file>
+
+<file path=ppt/notesSlides/notesSlide12.xml><?xml version="1.0" encoding="utf-8"?>
+<p:notes xmlns:a="http://schemas.openxmlformats.org/drawingml/2006/main" xmlns:r="http://schemas.openxmlformats.org/officeDocument/2006/relationships" xmlns:p="http://schemas.openxmlformats.org/presentationml/2006/main">
+  <p:cSld>
+    <p:spTree>
+      <p:nvGrpSpPr>
+        <p:cNvPr id="1" name=""/>
+        <p:cNvGrpSpPr/>
+        <p:nvPr/>
+      </p:nvGrpSpPr>
+      <p:grpSpPr>
+        <a:xfrm>
+          <a:off x="0" y="0"/>
+          <a:ext cx="0" cy="0"/>
+          <a:chOff x="0" y="0"/>
+          <a:chExt cx="0" cy="0"/>
+        </a:xfrm>
+      </p:grpSpPr>
+      <p:sp>
+        <p:nvSpPr>
+          <p:cNvPr id="2" name="Slide Image Placeholder 1"/>
+          <p:cNvSpPr>
+            <a:spLocks noGrp="1" noRot="1" noChangeAspect="1"/>
+          </p:cNvSpPr>
+          <p:nvPr>
+            <p:ph type="sldImg"/>
+          </p:nvPr>
+        </p:nvSpPr>
+        <p:spPr/>
+      </p:sp>
+      <p:sp>
+        <p:nvSpPr>
+          <p:cNvPr id="3" name="Notes Placeholder 2"/>
+          <p:cNvSpPr>
+            <a:spLocks noGrp="1"/>
+          </p:cNvSpPr>
+          <p:nvPr>
+            <p:ph type="body" idx="1"/>
+          </p:nvPr>
+        </p:nvSpPr>
+        <p:spPr/>
+        <p:txBody>
+          <a:bodyPr/>
+          <a:lstStyle/>
+          <a:p>
+            <a:r>
+              <a:rPr lang="en-HK" dirty="0"/>
+              <a:t>Step 3: After select() returns, we check the socket status. For server sockets, we accept new connections, and add to the </a:t>
+            </a:r>
+            <a:r>
+              <a:rPr lang="en-HK" dirty="0" err="1"/>
+              <a:t>client_sockets</a:t>
+            </a:r>
+            <a:r>
+              <a:rPr lang="en-HK" dirty="0"/>
+              <a:t> array </a:t>
+            </a:r>
+            <a:endParaRPr lang="en-US" dirty="0"/>
+          </a:p>
+        </p:txBody>
+      </p:sp>
+      <p:sp>
+        <p:nvSpPr>
+          <p:cNvPr id="4" name="Slide Number Placeholder 3"/>
+          <p:cNvSpPr>
+            <a:spLocks noGrp="1"/>
+          </p:cNvSpPr>
+          <p:nvPr>
+            <p:ph type="sldNum" sz="quarter" idx="5"/>
+          </p:nvPr>
+        </p:nvSpPr>
+        <p:spPr/>
+        <p:txBody>
+          <a:bodyPr/>
+          <a:lstStyle/>
+          <a:p>
+            <a:fld id="{54149050-F688-4072-B68F-BF1043D39F0B}" type="slidenum">
+              <a:rPr lang="zh-CN" altLang="en-US" smtClean="0"/>
+              <a:t>12</a:t>
+            </a:fld>
+            <a:endParaRPr lang="zh-CN" altLang="en-US"/>
+          </a:p>
+        </p:txBody>
+      </p:sp>
+    </p:spTree>
+    <p:extLst>
+      <p:ext uri="{BB962C8B-B14F-4D97-AF65-F5344CB8AC3E}">
+        <p14:creationId xmlns:p14="http://schemas.microsoft.com/office/powerpoint/2010/main" val="2652032353"/>
+      </p:ext>
+    </p:extLst>
+  </p:cSld>
+  <p:clrMapOvr>
+    <a:masterClrMapping/>
+  </p:clrMapOvr>
+</p:notes>
+</file>
+
+<file path=ppt/notesSlides/notesSlide13.xml><?xml version="1.0" encoding="utf-8"?>
+<p:notes xmlns:a="http://schemas.openxmlformats.org/drawingml/2006/main" xmlns:r="http://schemas.openxmlformats.org/officeDocument/2006/relationships" xmlns:p="http://schemas.openxmlformats.org/presentationml/2006/main">
+  <p:cSld>
+    <p:spTree>
+      <p:nvGrpSpPr>
+        <p:cNvPr id="1" name=""/>
+        <p:cNvGrpSpPr/>
+        <p:nvPr/>
+      </p:nvGrpSpPr>
+      <p:grpSpPr>
+        <a:xfrm>
+          <a:off x="0" y="0"/>
+          <a:ext cx="0" cy="0"/>
+          <a:chOff x="0" y="0"/>
+          <a:chExt cx="0" cy="0"/>
+        </a:xfrm>
+      </p:grpSpPr>
+      <p:sp>
+        <p:nvSpPr>
+          <p:cNvPr id="2" name="Slide Image Placeholder 1"/>
+          <p:cNvSpPr>
+            <a:spLocks noGrp="1" noRot="1" noChangeAspect="1"/>
+          </p:cNvSpPr>
+          <p:nvPr>
+            <p:ph type="sldImg"/>
+          </p:nvPr>
+        </p:nvSpPr>
+        <p:spPr/>
+      </p:sp>
+      <p:sp>
+        <p:nvSpPr>
+          <p:cNvPr id="3" name="Notes Placeholder 2"/>
+          <p:cNvSpPr>
+            <a:spLocks noGrp="1"/>
+          </p:cNvSpPr>
+          <p:nvPr>
+            <p:ph type="body" idx="1"/>
+          </p:nvPr>
+        </p:nvSpPr>
+        <p:spPr/>
+        <p:txBody>
+          <a:bodyPr/>
+          <a:lstStyle/>
+          <a:p>
+            <a:r>
+              <a:rPr lang="en-HK" dirty="0"/>
+              <a:t>and for client sockets, we handle incoming data or other operations.</a:t>
+            </a:r>
+            <a:endParaRPr lang="en-US" dirty="0"/>
+          </a:p>
+        </p:txBody>
+      </p:sp>
+      <p:sp>
+        <p:nvSpPr>
+          <p:cNvPr id="4" name="Slide Number Placeholder 3"/>
+          <p:cNvSpPr>
+            <a:spLocks noGrp="1"/>
+          </p:cNvSpPr>
+          <p:nvPr>
+            <p:ph type="sldNum" sz="quarter" idx="5"/>
+          </p:nvPr>
+        </p:nvSpPr>
+        <p:spPr/>
+        <p:txBody>
+          <a:bodyPr/>
+          <a:lstStyle/>
+          <a:p>
+            <a:fld id="{54149050-F688-4072-B68F-BF1043D39F0B}" type="slidenum">
+              <a:rPr lang="zh-CN" altLang="en-US" smtClean="0"/>
+              <a:t>13</a:t>
+            </a:fld>
+            <a:endParaRPr lang="zh-CN" altLang="en-US"/>
+          </a:p>
+        </p:txBody>
+      </p:sp>
+    </p:spTree>
+    <p:extLst>
+      <p:ext uri="{BB962C8B-B14F-4D97-AF65-F5344CB8AC3E}">
+        <p14:creationId xmlns:p14="http://schemas.microsoft.com/office/powerpoint/2010/main" val="3822423700"/>
+      </p:ext>
+    </p:extLst>
+  </p:cSld>
+  <p:clrMapOvr>
+    <a:masterClrMapping/>
+  </p:clrMapOvr>
+</p:notes>
+</file>
+
+<file path=ppt/notesSlides/notesSlide14.xml><?xml version="1.0" encoding="utf-8"?>
+<p:notes xmlns:a="http://schemas.openxmlformats.org/drawingml/2006/main" xmlns:r="http://schemas.openxmlformats.org/officeDocument/2006/relationships" xmlns:p="http://schemas.openxmlformats.org/presentationml/2006/main">
+  <p:cSld>
+    <p:spTree>
+      <p:nvGrpSpPr>
+        <p:cNvPr id="1" name=""/>
+        <p:cNvGrpSpPr/>
+        <p:nvPr/>
+      </p:nvGrpSpPr>
+      <p:grpSpPr>
+        <a:xfrm>
+          <a:off x="0" y="0"/>
+          <a:ext cx="0" cy="0"/>
+          <a:chOff x="0" y="0"/>
+          <a:chExt cx="0" cy="0"/>
+        </a:xfrm>
+      </p:grpSpPr>
+      <p:sp>
+        <p:nvSpPr>
+          <p:cNvPr id="2" name="Slide Image Placeholder 1"/>
+          <p:cNvSpPr>
+            <a:spLocks noGrp="1" noRot="1" noChangeAspect="1"/>
+          </p:cNvSpPr>
+          <p:nvPr>
+            <p:ph type="sldImg"/>
+          </p:nvPr>
+        </p:nvSpPr>
+        <p:spPr/>
+      </p:sp>
+      <p:sp>
+        <p:nvSpPr>
+          <p:cNvPr id="3" name="Notes Placeholder 2"/>
+          <p:cNvSpPr>
+            <a:spLocks noGrp="1"/>
+          </p:cNvSpPr>
+          <p:nvPr>
+            <p:ph type="body" idx="1"/>
+          </p:nvPr>
+        </p:nvSpPr>
+        <p:spPr/>
+        <p:txBody>
+          <a:bodyPr/>
+          <a:lstStyle/>
+          <a:p>
+            <a:r>
+              <a:rPr lang="en-HK" dirty="0"/>
+              <a:t>Now, let's look at a practical example - an echo server. This demo works on Linux or Mac OS systems. We'll use </a:t>
+            </a:r>
+            <a:r>
+              <a:rPr lang="en-HK" dirty="0" err="1"/>
+              <a:t>netcat</a:t>
+            </a:r>
+            <a:r>
+              <a:rPr lang="en-HK" dirty="0"/>
+              <a:t> (</a:t>
+            </a:r>
+            <a:r>
+              <a:rPr lang="en-HK" dirty="0" err="1"/>
+              <a:t>nc</a:t>
+            </a:r>
+            <a:r>
+              <a:rPr lang="en-HK" dirty="0"/>
+              <a:t> command) to test our server. This will help you understand how select() works in a real application.</a:t>
+            </a:r>
+            <a:endParaRPr lang="en-US" dirty="0"/>
+          </a:p>
+        </p:txBody>
+      </p:sp>
+      <p:sp>
+        <p:nvSpPr>
+          <p:cNvPr id="4" name="Slide Number Placeholder 3"/>
+          <p:cNvSpPr>
+            <a:spLocks noGrp="1"/>
+          </p:cNvSpPr>
+          <p:nvPr>
+            <p:ph type="sldNum" sz="quarter" idx="5"/>
+          </p:nvPr>
+        </p:nvSpPr>
+        <p:spPr/>
+        <p:txBody>
+          <a:bodyPr/>
+          <a:lstStyle/>
+          <a:p>
+            <a:fld id="{54149050-F688-4072-B68F-BF1043D39F0B}" type="slidenum">
+              <a:rPr lang="zh-CN" altLang="en-US" smtClean="0"/>
+              <a:t>14</a:t>
+            </a:fld>
+            <a:endParaRPr lang="zh-CN" altLang="en-US"/>
+          </a:p>
+        </p:txBody>
+      </p:sp>
+    </p:spTree>
+    <p:extLst>
+      <p:ext uri="{BB962C8B-B14F-4D97-AF65-F5344CB8AC3E}">
+        <p14:creationId xmlns:p14="http://schemas.microsoft.com/office/powerpoint/2010/main" val="3267899626"/>
+      </p:ext>
+    </p:extLst>
+  </p:cSld>
+  <p:clrMapOvr>
+    <a:masterClrMapping/>
+  </p:clrMapOvr>
+</p:notes>
+</file>
+
+<file path=ppt/notesSlides/notesSlide15.xml><?xml version="1.0" encoding="utf-8"?>
+<p:notes xmlns:a="http://schemas.openxmlformats.org/drawingml/2006/main" xmlns:r="http://schemas.openxmlformats.org/officeDocument/2006/relationships" xmlns:p="http://schemas.openxmlformats.org/presentationml/2006/main">
+  <p:cSld>
+    <p:spTree>
+      <p:nvGrpSpPr>
+        <p:cNvPr id="1" name=""/>
+        <p:cNvGrpSpPr/>
+        <p:nvPr/>
+      </p:nvGrpSpPr>
+      <p:grpSpPr>
+        <a:xfrm>
+          <a:off x="0" y="0"/>
+          <a:ext cx="0" cy="0"/>
+          <a:chOff x="0" y="0"/>
+          <a:chExt cx="0" cy="0"/>
+        </a:xfrm>
+      </p:grpSpPr>
+      <p:sp>
+        <p:nvSpPr>
+          <p:cNvPr id="2" name="Slide Image Placeholder 1"/>
+          <p:cNvSpPr>
+            <a:spLocks noGrp="1" noRot="1" noChangeAspect="1"/>
+          </p:cNvSpPr>
+          <p:nvPr>
+            <p:ph type="sldImg"/>
+          </p:nvPr>
+        </p:nvSpPr>
+        <p:spPr/>
+      </p:sp>
+      <p:sp>
+        <p:nvSpPr>
+          <p:cNvPr id="3" name="Notes Placeholder 2"/>
+          <p:cNvSpPr>
+            <a:spLocks noGrp="1"/>
+          </p:cNvSpPr>
+          <p:nvPr>
+            <p:ph type="body" idx="1"/>
+          </p:nvPr>
+        </p:nvSpPr>
+        <p:spPr/>
+        <p:txBody>
+          <a:bodyPr/>
+          <a:lstStyle/>
+          <a:p>
+            <a:r>
+              <a:rPr lang="en-HK" dirty="0"/>
+              <a:t>For further reference, here are some valuable resources:</a:t>
+            </a:r>
+            <a:endParaRPr lang="en-US" dirty="0"/>
+          </a:p>
+        </p:txBody>
+      </p:sp>
+      <p:sp>
+        <p:nvSpPr>
+          <p:cNvPr id="4" name="Slide Number Placeholder 3"/>
+          <p:cNvSpPr>
+            <a:spLocks noGrp="1"/>
+          </p:cNvSpPr>
+          <p:nvPr>
+            <p:ph type="sldNum" sz="quarter" idx="5"/>
+          </p:nvPr>
+        </p:nvSpPr>
+        <p:spPr/>
+        <p:txBody>
+          <a:bodyPr/>
+          <a:lstStyle/>
+          <a:p>
+            <a:fld id="{54149050-F688-4072-B68F-BF1043D39F0B}" type="slidenum">
+              <a:rPr lang="zh-CN" altLang="en-US" smtClean="0"/>
+              <a:t>15</a:t>
+            </a:fld>
+            <a:endParaRPr lang="zh-CN" altLang="en-US"/>
+          </a:p>
+        </p:txBody>
+      </p:sp>
+    </p:spTree>
+    <p:extLst>
+      <p:ext uri="{BB962C8B-B14F-4D97-AF65-F5344CB8AC3E}">
+        <p14:creationId xmlns:p14="http://schemas.microsoft.com/office/powerpoint/2010/main" val="4011635911"/>
       </p:ext>
     </p:extLst>
   </p:cSld>
@@ -1461,6 +2046,654 @@
       </p:grpSpPr>
       <p:sp>
         <p:nvSpPr>
+          <p:cNvPr id="2" name="Slide Image Placeholder 1"/>
+          <p:cNvSpPr>
+            <a:spLocks noGrp="1" noRot="1" noChangeAspect="1"/>
+          </p:cNvSpPr>
+          <p:nvPr>
+            <p:ph type="sldImg"/>
+          </p:nvPr>
+        </p:nvSpPr>
+        <p:spPr/>
+      </p:sp>
+      <p:sp>
+        <p:nvSpPr>
+          <p:cNvPr id="3" name="Notes Placeholder 2"/>
+          <p:cNvSpPr>
+            <a:spLocks noGrp="1"/>
+          </p:cNvSpPr>
+          <p:nvPr>
+            <p:ph type="body" idx="1"/>
+          </p:nvPr>
+        </p:nvSpPr>
+        <p:spPr/>
+        <p:txBody>
+          <a:bodyPr/>
+          <a:lstStyle/>
+          <a:p>
+            <a:r>
+              <a:rPr lang="en-HK" dirty="0"/>
+              <a:t>In today's tutorial, we'll cover two main topics. First, we'll introduce programming with the select() function, understanding its fundamentals and usage. Then, we'll look at a practical demonstration to reinforce these concepts.</a:t>
+            </a:r>
+            <a:endParaRPr lang="en-US" dirty="0"/>
+          </a:p>
+        </p:txBody>
+      </p:sp>
+      <p:sp>
+        <p:nvSpPr>
+          <p:cNvPr id="4" name="Slide Number Placeholder 3"/>
+          <p:cNvSpPr>
+            <a:spLocks noGrp="1"/>
+          </p:cNvSpPr>
+          <p:nvPr>
+            <p:ph type="sldNum" sz="quarter" idx="5"/>
+          </p:nvPr>
+        </p:nvSpPr>
+        <p:spPr/>
+        <p:txBody>
+          <a:bodyPr/>
+          <a:lstStyle/>
+          <a:p>
+            <a:fld id="{54149050-F688-4072-B68F-BF1043D39F0B}" type="slidenum">
+              <a:rPr lang="zh-CN" altLang="en-US" smtClean="0"/>
+              <a:t>2</a:t>
+            </a:fld>
+            <a:endParaRPr lang="zh-CN" altLang="en-US"/>
+          </a:p>
+        </p:txBody>
+      </p:sp>
+    </p:spTree>
+    <p:extLst>
+      <p:ext uri="{BB962C8B-B14F-4D97-AF65-F5344CB8AC3E}">
+        <p14:creationId xmlns:p14="http://schemas.microsoft.com/office/powerpoint/2010/main" val="1867210264"/>
+      </p:ext>
+    </p:extLst>
+  </p:cSld>
+  <p:clrMapOvr>
+    <a:masterClrMapping/>
+  </p:clrMapOvr>
+</p:notes>
+</file>
+
+<file path=ppt/notesSlides/notesSlide3.xml><?xml version="1.0" encoding="utf-8"?>
+<p:notes xmlns:a="http://schemas.openxmlformats.org/drawingml/2006/main" xmlns:r="http://schemas.openxmlformats.org/officeDocument/2006/relationships" xmlns:p="http://schemas.openxmlformats.org/presentationml/2006/main">
+  <p:cSld>
+    <p:spTree>
+      <p:nvGrpSpPr>
+        <p:cNvPr id="1" name=""/>
+        <p:cNvGrpSpPr/>
+        <p:nvPr/>
+      </p:nvGrpSpPr>
+      <p:grpSpPr>
+        <a:xfrm>
+          <a:off x="0" y="0"/>
+          <a:ext cx="0" cy="0"/>
+          <a:chOff x="0" y="0"/>
+          <a:chExt cx="0" cy="0"/>
+        </a:xfrm>
+      </p:grpSpPr>
+      <p:sp>
+        <p:nvSpPr>
+          <p:cNvPr id="2" name="Slide Image Placeholder 1"/>
+          <p:cNvSpPr>
+            <a:spLocks noGrp="1" noRot="1" noChangeAspect="1"/>
+          </p:cNvSpPr>
+          <p:nvPr>
+            <p:ph type="sldImg"/>
+          </p:nvPr>
+        </p:nvSpPr>
+        <p:spPr/>
+      </p:sp>
+      <p:sp>
+        <p:nvSpPr>
+          <p:cNvPr id="3" name="Notes Placeholder 2"/>
+          <p:cNvSpPr>
+            <a:spLocks noGrp="1"/>
+          </p:cNvSpPr>
+          <p:nvPr>
+            <p:ph type="body" idx="1"/>
+          </p:nvPr>
+        </p:nvSpPr>
+        <p:spPr/>
+        <p:txBody>
+          <a:bodyPr/>
+          <a:lstStyle/>
+          <a:p>
+            <a:r>
+              <a:rPr lang="en-HK" dirty="0"/>
+              <a:t>Let's start with understanding select(). This function is a powerful tool for I/O Multiplexing. What does that mean? Select() allows a program to monitor multiple file descriptors simultaneously, waiting until one or more becomes 'ready' for I/O operations. This is particularly useful in network programming where we need to handle multiple connections.</a:t>
+            </a:r>
+            <a:endParaRPr lang="en-US" dirty="0"/>
+          </a:p>
+        </p:txBody>
+      </p:sp>
+      <p:sp>
+        <p:nvSpPr>
+          <p:cNvPr id="4" name="Slide Number Placeholder 3"/>
+          <p:cNvSpPr>
+            <a:spLocks noGrp="1"/>
+          </p:cNvSpPr>
+          <p:nvPr>
+            <p:ph type="sldNum" sz="quarter" idx="5"/>
+          </p:nvPr>
+        </p:nvSpPr>
+        <p:spPr/>
+        <p:txBody>
+          <a:bodyPr/>
+          <a:lstStyle/>
+          <a:p>
+            <a:fld id="{54149050-F688-4072-B68F-BF1043D39F0B}" type="slidenum">
+              <a:rPr lang="zh-CN" altLang="en-US" smtClean="0"/>
+              <a:t>3</a:t>
+            </a:fld>
+            <a:endParaRPr lang="zh-CN" altLang="en-US"/>
+          </a:p>
+        </p:txBody>
+      </p:sp>
+    </p:spTree>
+    <p:extLst>
+      <p:ext uri="{BB962C8B-B14F-4D97-AF65-F5344CB8AC3E}">
+        <p14:creationId xmlns:p14="http://schemas.microsoft.com/office/powerpoint/2010/main" val="1266168854"/>
+      </p:ext>
+    </p:extLst>
+  </p:cSld>
+  <p:clrMapOvr>
+    <a:masterClrMapping/>
+  </p:clrMapOvr>
+</p:notes>
+</file>
+
+<file path=ppt/notesSlides/notesSlide4.xml><?xml version="1.0" encoding="utf-8"?>
+<p:notes xmlns:a="http://schemas.openxmlformats.org/drawingml/2006/main" xmlns:r="http://schemas.openxmlformats.org/officeDocument/2006/relationships" xmlns:p="http://schemas.openxmlformats.org/presentationml/2006/main">
+  <p:cSld>
+    <p:spTree>
+      <p:nvGrpSpPr>
+        <p:cNvPr id="1" name=""/>
+        <p:cNvGrpSpPr/>
+        <p:nvPr/>
+      </p:nvGrpSpPr>
+      <p:grpSpPr>
+        <a:xfrm>
+          <a:off x="0" y="0"/>
+          <a:ext cx="0" cy="0"/>
+          <a:chOff x="0" y="0"/>
+          <a:chExt cx="0" cy="0"/>
+        </a:xfrm>
+      </p:grpSpPr>
+      <p:sp>
+        <p:nvSpPr>
+          <p:cNvPr id="2" name="幻灯片图像占位符 1"/>
+          <p:cNvSpPr>
+            <a:spLocks noGrp="1" noRot="1" noChangeAspect="1"/>
+          </p:cNvSpPr>
+          <p:nvPr>
+            <p:ph type="sldImg"/>
+          </p:nvPr>
+        </p:nvSpPr>
+        <p:spPr/>
+      </p:sp>
+      <p:sp>
+        <p:nvSpPr>
+          <p:cNvPr id="3" name="备注占位符 2"/>
+          <p:cNvSpPr>
+            <a:spLocks noGrp="1"/>
+          </p:cNvSpPr>
+          <p:nvPr>
+            <p:ph type="body" idx="1"/>
+          </p:nvPr>
+        </p:nvSpPr>
+        <p:spPr/>
+        <p:txBody>
+          <a:bodyPr/>
+          <a:lstStyle/>
+          <a:p>
+            <a:r>
+              <a:rPr lang="en-US" altLang="zh-CN" dirty="0"/>
+              <a:t>Less CPU/DRAM/context switching/ not need to using lock for sync</a:t>
+            </a:r>
+            <a:br>
+              <a:rPr lang="en-US" altLang="zh-CN" dirty="0"/>
+            </a:br>
+            <a:br>
+              <a:rPr lang="en-US" altLang="zh-CN" dirty="0"/>
+            </a:br>
+            <a:r>
+              <a:rPr lang="en-HK" dirty="0"/>
+              <a:t>You might wonder: why use select() when we could use multi-threading? The key advantage is that select() provides non-blocking functionality in a single-threaded program. This means it requires fewer system resources compared to creating multiple threads. While the code might be more complex to write, it's more efficient in terms of resource utilization.</a:t>
+            </a:r>
+            <a:endParaRPr lang="zh-CN" altLang="en-US" dirty="0"/>
+          </a:p>
+        </p:txBody>
+      </p:sp>
+      <p:sp>
+        <p:nvSpPr>
+          <p:cNvPr id="4" name="灯片编号占位符 3"/>
+          <p:cNvSpPr>
+            <a:spLocks noGrp="1"/>
+          </p:cNvSpPr>
+          <p:nvPr>
+            <p:ph type="sldNum" sz="quarter" idx="5"/>
+          </p:nvPr>
+        </p:nvSpPr>
+        <p:spPr/>
+        <p:txBody>
+          <a:bodyPr/>
+          <a:lstStyle/>
+          <a:p>
+            <a:fld id="{54149050-F688-4072-B68F-BF1043D39F0B}" type="slidenum">
+              <a:rPr lang="zh-CN" altLang="en-US" smtClean="0"/>
+              <a:t>4</a:t>
+            </a:fld>
+            <a:endParaRPr lang="zh-CN" altLang="en-US"/>
+          </a:p>
+        </p:txBody>
+      </p:sp>
+    </p:spTree>
+    <p:extLst>
+      <p:ext uri="{BB962C8B-B14F-4D97-AF65-F5344CB8AC3E}">
+        <p14:creationId xmlns:p14="http://schemas.microsoft.com/office/powerpoint/2010/main" val="2384694073"/>
+      </p:ext>
+    </p:extLst>
+  </p:cSld>
+  <p:clrMapOvr>
+    <a:masterClrMapping/>
+  </p:clrMapOvr>
+</p:notes>
+</file>
+
+<file path=ppt/notesSlides/notesSlide5.xml><?xml version="1.0" encoding="utf-8"?>
+<p:notes xmlns:a="http://schemas.openxmlformats.org/drawingml/2006/main" xmlns:r="http://schemas.openxmlformats.org/officeDocument/2006/relationships" xmlns:p="http://schemas.openxmlformats.org/presentationml/2006/main">
+  <p:cSld>
+    <p:spTree>
+      <p:nvGrpSpPr>
+        <p:cNvPr id="1" name=""/>
+        <p:cNvGrpSpPr/>
+        <p:nvPr/>
+      </p:nvGrpSpPr>
+      <p:grpSpPr>
+        <a:xfrm>
+          <a:off x="0" y="0"/>
+          <a:ext cx="0" cy="0"/>
+          <a:chOff x="0" y="0"/>
+          <a:chExt cx="0" cy="0"/>
+        </a:xfrm>
+      </p:grpSpPr>
+      <p:sp>
+        <p:nvSpPr>
+          <p:cNvPr id="2" name="Slide Image Placeholder 1"/>
+          <p:cNvSpPr>
+            <a:spLocks noGrp="1" noRot="1" noChangeAspect="1"/>
+          </p:cNvSpPr>
+          <p:nvPr>
+            <p:ph type="sldImg"/>
+          </p:nvPr>
+        </p:nvSpPr>
+        <p:spPr/>
+      </p:sp>
+      <p:sp>
+        <p:nvSpPr>
+          <p:cNvPr id="3" name="Notes Placeholder 2"/>
+          <p:cNvSpPr>
+            <a:spLocks noGrp="1"/>
+          </p:cNvSpPr>
+          <p:nvPr>
+            <p:ph type="body" idx="1"/>
+          </p:nvPr>
+        </p:nvSpPr>
+        <p:spPr/>
+        <p:txBody>
+          <a:bodyPr/>
+          <a:lstStyle/>
+          <a:p>
+            <a:r>
+              <a:rPr lang="en-HK" dirty="0"/>
+              <a:t>Here we introduce a crucial data structure: </a:t>
+            </a:r>
+            <a:r>
+              <a:rPr lang="en-HK" dirty="0" err="1"/>
+              <a:t>fd_set</a:t>
+            </a:r>
+            <a:r>
+              <a:rPr lang="en-HK" dirty="0"/>
+              <a:t>. This is a special data type used in Unix and Unix-like systems to store a set of file descriptors. It's particularly important when working with select() as it helps us keep track of multiple socket descriptors we want to monitor.</a:t>
+            </a:r>
+            <a:endParaRPr lang="en-US" dirty="0"/>
+          </a:p>
+        </p:txBody>
+      </p:sp>
+      <p:sp>
+        <p:nvSpPr>
+          <p:cNvPr id="4" name="Slide Number Placeholder 3"/>
+          <p:cNvSpPr>
+            <a:spLocks noGrp="1"/>
+          </p:cNvSpPr>
+          <p:nvPr>
+            <p:ph type="sldNum" sz="quarter" idx="5"/>
+          </p:nvPr>
+        </p:nvSpPr>
+        <p:spPr/>
+        <p:txBody>
+          <a:bodyPr/>
+          <a:lstStyle/>
+          <a:p>
+            <a:fld id="{54149050-F688-4072-B68F-BF1043D39F0B}" type="slidenum">
+              <a:rPr lang="zh-CN" altLang="en-US" smtClean="0"/>
+              <a:t>5</a:t>
+            </a:fld>
+            <a:endParaRPr lang="zh-CN" altLang="en-US"/>
+          </a:p>
+        </p:txBody>
+      </p:sp>
+    </p:spTree>
+    <p:extLst>
+      <p:ext uri="{BB962C8B-B14F-4D97-AF65-F5344CB8AC3E}">
+        <p14:creationId xmlns:p14="http://schemas.microsoft.com/office/powerpoint/2010/main" val="3713729928"/>
+      </p:ext>
+    </p:extLst>
+  </p:cSld>
+  <p:clrMapOvr>
+    <a:masterClrMapping/>
+  </p:clrMapOvr>
+</p:notes>
+</file>
+
+<file path=ppt/notesSlides/notesSlide6.xml><?xml version="1.0" encoding="utf-8"?>
+<p:notes xmlns:a="http://schemas.openxmlformats.org/drawingml/2006/main" xmlns:r="http://schemas.openxmlformats.org/officeDocument/2006/relationships" xmlns:p="http://schemas.openxmlformats.org/presentationml/2006/main">
+  <p:cSld>
+    <p:spTree>
+      <p:nvGrpSpPr>
+        <p:cNvPr id="1" name=""/>
+        <p:cNvGrpSpPr/>
+        <p:nvPr/>
+      </p:nvGrpSpPr>
+      <p:grpSpPr>
+        <a:xfrm>
+          <a:off x="0" y="0"/>
+          <a:ext cx="0" cy="0"/>
+          <a:chOff x="0" y="0"/>
+          <a:chExt cx="0" cy="0"/>
+        </a:xfrm>
+      </p:grpSpPr>
+      <p:sp>
+        <p:nvSpPr>
+          <p:cNvPr id="2" name="Slide Image Placeholder 1"/>
+          <p:cNvSpPr>
+            <a:spLocks noGrp="1" noRot="1" noChangeAspect="1"/>
+          </p:cNvSpPr>
+          <p:nvPr>
+            <p:ph type="sldImg"/>
+          </p:nvPr>
+        </p:nvSpPr>
+        <p:spPr/>
+      </p:sp>
+      <p:sp>
+        <p:nvSpPr>
+          <p:cNvPr id="3" name="Notes Placeholder 2"/>
+          <p:cNvSpPr>
+            <a:spLocks noGrp="1"/>
+          </p:cNvSpPr>
+          <p:nvPr>
+            <p:ph type="body" idx="1"/>
+          </p:nvPr>
+        </p:nvSpPr>
+        <p:spPr/>
+        <p:txBody>
+          <a:bodyPr/>
+          <a:lstStyle/>
+          <a:p>
+            <a:r>
+              <a:rPr lang="en-HK" dirty="0"/>
+              <a:t>There are several important macros we use with </a:t>
+            </a:r>
+            <a:r>
+              <a:rPr lang="en-HK" dirty="0" err="1"/>
+              <a:t>fd_set</a:t>
+            </a:r>
+            <a:r>
+              <a:rPr lang="en-HK" dirty="0"/>
+              <a:t>:</a:t>
+            </a:r>
+          </a:p>
+          <a:p>
+            <a:pPr>
+              <a:buFont typeface="Arial" panose="020B0604020202020204" pitchFamily="34" charset="0"/>
+              <a:buChar char="•"/>
+            </a:pPr>
+            <a:r>
+              <a:rPr lang="en-HK" dirty="0"/>
+              <a:t>FD_ZERO() clears all bits in the set</a:t>
+            </a:r>
+          </a:p>
+          <a:p>
+            <a:pPr>
+              <a:buFont typeface="Arial" panose="020B0604020202020204" pitchFamily="34" charset="0"/>
+              <a:buChar char="•"/>
+            </a:pPr>
+            <a:r>
+              <a:rPr lang="en-HK" dirty="0"/>
+              <a:t>FD_SET() adds a file descriptor to the set</a:t>
+            </a:r>
+          </a:p>
+          <a:p>
+            <a:pPr>
+              <a:buFont typeface="Arial" panose="020B0604020202020204" pitchFamily="34" charset="0"/>
+              <a:buChar char="•"/>
+            </a:pPr>
+            <a:r>
+              <a:rPr lang="en-HK" dirty="0"/>
+              <a:t>FD_CLR() removes a file descriptor from the set</a:t>
+            </a:r>
+          </a:p>
+          <a:p>
+            <a:pPr>
+              <a:buFont typeface="Arial" panose="020B0604020202020204" pitchFamily="34" charset="0"/>
+              <a:buChar char="•"/>
+            </a:pPr>
+            <a:r>
+              <a:rPr lang="en-HK" dirty="0"/>
+              <a:t>FD_ISSET() tests if a file descriptor is part of the set</a:t>
+            </a:r>
+          </a:p>
+          <a:p>
+            <a:endParaRPr lang="en-US" dirty="0"/>
+          </a:p>
+        </p:txBody>
+      </p:sp>
+      <p:sp>
+        <p:nvSpPr>
+          <p:cNvPr id="4" name="Slide Number Placeholder 3"/>
+          <p:cNvSpPr>
+            <a:spLocks noGrp="1"/>
+          </p:cNvSpPr>
+          <p:nvPr>
+            <p:ph type="sldNum" sz="quarter" idx="5"/>
+          </p:nvPr>
+        </p:nvSpPr>
+        <p:spPr/>
+        <p:txBody>
+          <a:bodyPr/>
+          <a:lstStyle/>
+          <a:p>
+            <a:fld id="{54149050-F688-4072-B68F-BF1043D39F0B}" type="slidenum">
+              <a:rPr lang="zh-CN" altLang="en-US" smtClean="0"/>
+              <a:t>6</a:t>
+            </a:fld>
+            <a:endParaRPr lang="zh-CN" altLang="en-US"/>
+          </a:p>
+        </p:txBody>
+      </p:sp>
+    </p:spTree>
+    <p:extLst>
+      <p:ext uri="{BB962C8B-B14F-4D97-AF65-F5344CB8AC3E}">
+        <p14:creationId xmlns:p14="http://schemas.microsoft.com/office/powerpoint/2010/main" val="3614282613"/>
+      </p:ext>
+    </p:extLst>
+  </p:cSld>
+  <p:clrMapOvr>
+    <a:masterClrMapping/>
+  </p:clrMapOvr>
+</p:notes>
+</file>
+
+<file path=ppt/notesSlides/notesSlide7.xml><?xml version="1.0" encoding="utf-8"?>
+<p:notes xmlns:a="http://schemas.openxmlformats.org/drawingml/2006/main" xmlns:r="http://schemas.openxmlformats.org/officeDocument/2006/relationships" xmlns:p="http://schemas.openxmlformats.org/presentationml/2006/main">
+  <p:cSld>
+    <p:spTree>
+      <p:nvGrpSpPr>
+        <p:cNvPr id="1" name=""/>
+        <p:cNvGrpSpPr/>
+        <p:nvPr/>
+      </p:nvGrpSpPr>
+      <p:grpSpPr>
+        <a:xfrm>
+          <a:off x="0" y="0"/>
+          <a:ext cx="0" cy="0"/>
+          <a:chOff x="0" y="0"/>
+          <a:chExt cx="0" cy="0"/>
+        </a:xfrm>
+      </p:grpSpPr>
+      <p:sp>
+        <p:nvSpPr>
+          <p:cNvPr id="2" name="Slide Image Placeholder 1"/>
+          <p:cNvSpPr>
+            <a:spLocks noGrp="1" noRot="1" noChangeAspect="1"/>
+          </p:cNvSpPr>
+          <p:nvPr>
+            <p:ph type="sldImg"/>
+          </p:nvPr>
+        </p:nvSpPr>
+        <p:spPr/>
+      </p:sp>
+      <p:sp>
+        <p:nvSpPr>
+          <p:cNvPr id="3" name="Notes Placeholder 2"/>
+          <p:cNvSpPr>
+            <a:spLocks noGrp="1"/>
+          </p:cNvSpPr>
+          <p:nvPr>
+            <p:ph type="body" idx="1"/>
+          </p:nvPr>
+        </p:nvSpPr>
+        <p:spPr/>
+        <p:txBody>
+          <a:bodyPr/>
+          <a:lstStyle/>
+          <a:p>
+            <a:r>
+              <a:rPr lang="en-HK" dirty="0"/>
+              <a:t>The select() function has several important properties:</a:t>
+            </a:r>
+          </a:p>
+          <a:p>
+            <a:pPr>
+              <a:buFont typeface="+mj-lt"/>
+              <a:buAutoNum type="arabicPeriod"/>
+            </a:pPr>
+            <a:r>
+              <a:rPr lang="en-HK" dirty="0"/>
+              <a:t>It's a blocking operation - it pauses program execution until activity occurs</a:t>
+            </a:r>
+          </a:p>
+          <a:p>
+            <a:pPr>
+              <a:buFont typeface="+mj-lt"/>
+              <a:buAutoNum type="arabicPeriod"/>
+            </a:pPr>
+            <a:r>
+              <a:rPr lang="en-HK" dirty="0"/>
+              <a:t>It returns a number indicating what happened: </a:t>
+            </a:r>
+          </a:p>
+          <a:p>
+            <a:pPr marL="742950" lvl="1" indent="-285750">
+              <a:buFont typeface="+mj-lt"/>
+              <a:buAutoNum type="arabicPeriod"/>
+            </a:pPr>
+            <a:r>
+              <a:rPr lang="en-HK" dirty="0"/>
+              <a:t>Positive number means activity occurred on some sockets</a:t>
+            </a:r>
+          </a:p>
+          <a:p>
+            <a:pPr marL="742950" lvl="1" indent="-285750">
+              <a:buFont typeface="+mj-lt"/>
+              <a:buAutoNum type="arabicPeriod"/>
+            </a:pPr>
+            <a:r>
+              <a:rPr lang="en-HK" dirty="0"/>
+              <a:t>Zero means a timeout occurred with no activity</a:t>
+            </a:r>
+          </a:p>
+          <a:p>
+            <a:pPr marL="742950" lvl="1" indent="-285750">
+              <a:buFont typeface="+mj-lt"/>
+              <a:buAutoNum type="arabicPeriod"/>
+            </a:pPr>
+            <a:r>
+              <a:rPr lang="en-HK" dirty="0"/>
+              <a:t>Negative number indicates an error occurred"</a:t>
+            </a:r>
+          </a:p>
+          <a:p>
+            <a:endParaRPr lang="en-US" dirty="0"/>
+          </a:p>
+        </p:txBody>
+      </p:sp>
+      <p:sp>
+        <p:nvSpPr>
+          <p:cNvPr id="4" name="Slide Number Placeholder 3"/>
+          <p:cNvSpPr>
+            <a:spLocks noGrp="1"/>
+          </p:cNvSpPr>
+          <p:nvPr>
+            <p:ph type="sldNum" sz="quarter" idx="5"/>
+          </p:nvPr>
+        </p:nvSpPr>
+        <p:spPr/>
+        <p:txBody>
+          <a:bodyPr/>
+          <a:lstStyle/>
+          <a:p>
+            <a:fld id="{54149050-F688-4072-B68F-BF1043D39F0B}" type="slidenum">
+              <a:rPr lang="zh-CN" altLang="en-US" smtClean="0"/>
+              <a:t>7</a:t>
+            </a:fld>
+            <a:endParaRPr lang="zh-CN" altLang="en-US"/>
+          </a:p>
+        </p:txBody>
+      </p:sp>
+    </p:spTree>
+    <p:extLst>
+      <p:ext uri="{BB962C8B-B14F-4D97-AF65-F5344CB8AC3E}">
+        <p14:creationId xmlns:p14="http://schemas.microsoft.com/office/powerpoint/2010/main" val="4132291770"/>
+      </p:ext>
+    </p:extLst>
+  </p:cSld>
+  <p:clrMapOvr>
+    <a:masterClrMapping/>
+  </p:clrMapOvr>
+</p:notes>
+</file>
+
+<file path=ppt/notesSlides/notesSlide8.xml><?xml version="1.0" encoding="utf-8"?>
+<p:notes xmlns:a="http://schemas.openxmlformats.org/drawingml/2006/main" xmlns:r="http://schemas.openxmlformats.org/officeDocument/2006/relationships" xmlns:p="http://schemas.openxmlformats.org/presentationml/2006/main">
+  <p:cSld>
+    <p:spTree>
+      <p:nvGrpSpPr>
+        <p:cNvPr id="1" name=""/>
+        <p:cNvGrpSpPr/>
+        <p:nvPr/>
+      </p:nvGrpSpPr>
+      <p:grpSpPr>
+        <a:xfrm>
+          <a:off x="0" y="0"/>
+          <a:ext cx="0" cy="0"/>
+          <a:chOff x="0" y="0"/>
+          <a:chExt cx="0" cy="0"/>
+        </a:xfrm>
+      </p:grpSpPr>
+      <p:sp>
+        <p:nvSpPr>
           <p:cNvPr id="2" name="幻灯片图像占位符 1"/>
           <p:cNvSpPr>
             <a:spLocks noGrp="1" noRot="1" noChangeAspect="1"/>
@@ -1521,6 +2754,94 @@
     <p:extLst>
       <p:ext uri="{BB962C8B-B14F-4D97-AF65-F5344CB8AC3E}">
         <p14:creationId xmlns:p14="http://schemas.microsoft.com/office/powerpoint/2010/main" val="2125186014"/>
+      </p:ext>
+    </p:extLst>
+  </p:cSld>
+  <p:clrMapOvr>
+    <a:masterClrMapping/>
+  </p:clrMapOvr>
+</p:notes>
+</file>
+
+<file path=ppt/notesSlides/notesSlide9.xml><?xml version="1.0" encoding="utf-8"?>
+<p:notes xmlns:a="http://schemas.openxmlformats.org/drawingml/2006/main" xmlns:r="http://schemas.openxmlformats.org/officeDocument/2006/relationships" xmlns:p="http://schemas.openxmlformats.org/presentationml/2006/main">
+  <p:cSld>
+    <p:spTree>
+      <p:nvGrpSpPr>
+        <p:cNvPr id="1" name=""/>
+        <p:cNvGrpSpPr/>
+        <p:nvPr/>
+      </p:nvGrpSpPr>
+      <p:grpSpPr>
+        <a:xfrm>
+          <a:off x="0" y="0"/>
+          <a:ext cx="0" cy="0"/>
+          <a:chOff x="0" y="0"/>
+          <a:chExt cx="0" cy="0"/>
+        </a:xfrm>
+      </p:grpSpPr>
+      <p:sp>
+        <p:nvSpPr>
+          <p:cNvPr id="2" name="Slide Image Placeholder 1"/>
+          <p:cNvSpPr>
+            <a:spLocks noGrp="1" noRot="1" noChangeAspect="1"/>
+          </p:cNvSpPr>
+          <p:nvPr>
+            <p:ph type="sldImg"/>
+          </p:nvPr>
+        </p:nvSpPr>
+        <p:spPr/>
+      </p:sp>
+      <p:sp>
+        <p:nvSpPr>
+          <p:cNvPr id="3" name="Notes Placeholder 2"/>
+          <p:cNvSpPr>
+            <a:spLocks noGrp="1"/>
+          </p:cNvSpPr>
+          <p:nvPr>
+            <p:ph type="body" idx="1"/>
+          </p:nvPr>
+        </p:nvSpPr>
+        <p:spPr/>
+        <p:txBody>
+          <a:bodyPr/>
+          <a:lstStyle/>
+          <a:p>
+            <a:r>
+              <a:rPr lang="en-HK" dirty="0"/>
+              <a:t>These diagrams illustrate how select() works. Notice how it monitors multiple file descriptors and returns when any of them becomes ready for I/O operations. This is particularly useful in server applications where we need to handle multiple client connections simultaneously.</a:t>
+            </a:r>
+            <a:endParaRPr lang="en-US" dirty="0"/>
+          </a:p>
+        </p:txBody>
+      </p:sp>
+      <p:sp>
+        <p:nvSpPr>
+          <p:cNvPr id="4" name="Slide Number Placeholder 3"/>
+          <p:cNvSpPr>
+            <a:spLocks noGrp="1"/>
+          </p:cNvSpPr>
+          <p:nvPr>
+            <p:ph type="sldNum" sz="quarter" idx="5"/>
+          </p:nvPr>
+        </p:nvSpPr>
+        <p:spPr/>
+        <p:txBody>
+          <a:bodyPr/>
+          <a:lstStyle/>
+          <a:p>
+            <a:fld id="{54149050-F688-4072-B68F-BF1043D39F0B}" type="slidenum">
+              <a:rPr lang="zh-CN" altLang="en-US" smtClean="0"/>
+              <a:t>9</a:t>
+            </a:fld>
+            <a:endParaRPr lang="zh-CN" altLang="en-US"/>
+          </a:p>
+        </p:txBody>
+      </p:sp>
+    </p:spTree>
+    <p:extLst>
+      <p:ext uri="{BB962C8B-B14F-4D97-AF65-F5344CB8AC3E}">
+        <p14:creationId xmlns:p14="http://schemas.microsoft.com/office/powerpoint/2010/main" val="3143746716"/>
       </p:ext>
     </p:extLst>
   </p:cSld>
@@ -1679,7 +3000,7 @@
           <a:p>
             <a:fld id="{2425905D-C0C4-D040-B3F5-79CCA23FA4EB}" type="datetimeFigureOut">
               <a:rPr lang="en-US" smtClean="0"/>
-              <a:t>2/2/25</a:t>
+              <a:t>2/5/25</a:t>
             </a:fld>
             <a:endParaRPr lang="en-US"/>
           </a:p>
@@ -1879,7 +3200,7 @@
           <a:p>
             <a:fld id="{2425905D-C0C4-D040-B3F5-79CCA23FA4EB}" type="datetimeFigureOut">
               <a:rPr lang="en-US" smtClean="0"/>
-              <a:t>2/2/25</a:t>
+              <a:t>2/5/25</a:t>
             </a:fld>
             <a:endParaRPr lang="en-US"/>
           </a:p>
@@ -2089,7 +3410,7 @@
           <a:p>
             <a:fld id="{2425905D-C0C4-D040-B3F5-79CCA23FA4EB}" type="datetimeFigureOut">
               <a:rPr lang="en-US" smtClean="0"/>
-              <a:t>2/2/25</a:t>
+              <a:t>2/5/25</a:t>
             </a:fld>
             <a:endParaRPr lang="en-US"/>
           </a:p>
@@ -2289,7 +3610,7 @@
           <a:p>
             <a:fld id="{2425905D-C0C4-D040-B3F5-79CCA23FA4EB}" type="datetimeFigureOut">
               <a:rPr lang="en-US" smtClean="0"/>
-              <a:t>2/2/25</a:t>
+              <a:t>2/5/25</a:t>
             </a:fld>
             <a:endParaRPr lang="en-US"/>
           </a:p>
@@ -2565,7 +3886,7 @@
           <a:p>
             <a:fld id="{2425905D-C0C4-D040-B3F5-79CCA23FA4EB}" type="datetimeFigureOut">
               <a:rPr lang="en-US" smtClean="0"/>
-              <a:t>2/2/25</a:t>
+              <a:t>2/5/25</a:t>
             </a:fld>
             <a:endParaRPr lang="en-US"/>
           </a:p>
@@ -2833,7 +4154,7 @@
           <a:p>
             <a:fld id="{2425905D-C0C4-D040-B3F5-79CCA23FA4EB}" type="datetimeFigureOut">
               <a:rPr lang="en-US" smtClean="0"/>
-              <a:t>2/2/25</a:t>
+              <a:t>2/5/25</a:t>
             </a:fld>
             <a:endParaRPr lang="en-US"/>
           </a:p>
@@ -3248,7 +4569,7 @@
           <a:p>
             <a:fld id="{2425905D-C0C4-D040-B3F5-79CCA23FA4EB}" type="datetimeFigureOut">
               <a:rPr lang="en-US" smtClean="0"/>
-              <a:t>2/2/25</a:t>
+              <a:t>2/5/25</a:t>
             </a:fld>
             <a:endParaRPr lang="en-US"/>
           </a:p>
@@ -3390,7 +4711,7 @@
           <a:p>
             <a:fld id="{2425905D-C0C4-D040-B3F5-79CCA23FA4EB}" type="datetimeFigureOut">
               <a:rPr lang="en-US" smtClean="0"/>
-              <a:t>2/2/25</a:t>
+              <a:t>2/5/25</a:t>
             </a:fld>
             <a:endParaRPr lang="en-US"/>
           </a:p>
@@ -3503,7 +4824,7 @@
           <a:p>
             <a:fld id="{2425905D-C0C4-D040-B3F5-79CCA23FA4EB}" type="datetimeFigureOut">
               <a:rPr lang="en-US" smtClean="0"/>
-              <a:t>2/2/25</a:t>
+              <a:t>2/5/25</a:t>
             </a:fld>
             <a:endParaRPr lang="en-US"/>
           </a:p>
@@ -3816,7 +5137,7 @@
           <a:p>
             <a:fld id="{2425905D-C0C4-D040-B3F5-79CCA23FA4EB}" type="datetimeFigureOut">
               <a:rPr lang="en-US" smtClean="0"/>
-              <a:t>2/2/25</a:t>
+              <a:t>2/5/25</a:t>
             </a:fld>
             <a:endParaRPr lang="en-US"/>
           </a:p>
@@ -4105,7 +5426,7 @@
           <a:p>
             <a:fld id="{2425905D-C0C4-D040-B3F5-79CCA23FA4EB}" type="datetimeFigureOut">
               <a:rPr lang="en-US" smtClean="0"/>
-              <a:t>2/2/25</a:t>
+              <a:t>2/5/25</a:t>
             </a:fld>
             <a:endParaRPr lang="en-US"/>
           </a:p>
@@ -4348,7 +5669,7 @@
           <a:p>
             <a:fld id="{2425905D-C0C4-D040-B3F5-79CCA23FA4EB}" type="datetimeFigureOut">
               <a:rPr lang="en-US" smtClean="0"/>
-              <a:t>2/2/25</a:t>
+              <a:t>2/5/25</a:t>
             </a:fld>
             <a:endParaRPr lang="en-US"/>
           </a:p>
@@ -4852,7 +6173,7 @@
           <a:p>
             <a:r>
               <a:rPr lang="en-US" sz="2800" b="1" dirty="0">
-                <a:hlinkClick r:id="rId2"/>
+                <a:hlinkClick r:id="rId3"/>
               </a:rPr>
               <a:t>ytyang@cse.cuhk.edu.hk</a:t>
             </a:r>
@@ -4902,7 +6223,7 @@
           <p:nvPr/>
         </p:nvPicPr>
         <p:blipFill>
-          <a:blip r:embed="rId3"/>
+          <a:blip r:embed="rId4"/>
           <a:stretch>
             <a:fillRect/>
           </a:stretch>
@@ -5020,7 +6341,7 @@
           <p:nvPr/>
         </p:nvPicPr>
         <p:blipFill>
-          <a:blip r:embed="rId2"/>
+          <a:blip r:embed="rId3"/>
           <a:stretch>
             <a:fillRect/>
           </a:stretch>
@@ -5528,7 +6849,7 @@
           <p:nvPr/>
         </p:nvPicPr>
         <p:blipFill>
-          <a:blip r:embed="rId2"/>
+          <a:blip r:embed="rId3"/>
           <a:stretch>
             <a:fillRect/>
           </a:stretch>
@@ -5891,7 +7212,7 @@
           <p:nvPr/>
         </p:nvPicPr>
         <p:blipFill>
-          <a:blip r:embed="rId2"/>
+          <a:blip r:embed="rId3"/>
           <a:stretch>
             <a:fillRect/>
           </a:stretch>
@@ -6264,15 +7585,15 @@
           <p:nvPr/>
         </p:nvPicPr>
         <p:blipFill>
-          <a:blip r:embed="rId2"/>
+          <a:blip r:embed="rId3"/>
           <a:stretch>
             <a:fillRect/>
           </a:stretch>
         </p:blipFill>
         <p:spPr>
           <a:xfrm>
-            <a:off x="2589995" y="2107208"/>
-            <a:ext cx="6287305" cy="4213921"/>
+            <a:off x="2461001" y="1730830"/>
+            <a:ext cx="6824513" cy="4573972"/>
           </a:xfrm>
           <a:prstGeom prst="rect">
             <a:avLst/>
@@ -6395,19 +7716,19 @@
             </a:r>
             <a:r>
               <a:rPr lang="en-US" altLang="zh-CN" dirty="0">
-                <a:hlinkClick r:id="rId2"/>
+                <a:hlinkClick r:id="rId3"/>
               </a:rPr>
               <a:t>echo</a:t>
             </a:r>
             <a:r>
               <a:rPr lang="zh-CN" altLang="en-US" dirty="0">
-                <a:hlinkClick r:id="rId2"/>
+                <a:hlinkClick r:id="rId3"/>
               </a:rPr>
               <a:t> </a:t>
             </a:r>
             <a:r>
               <a:rPr lang="en-US" altLang="zh-CN" dirty="0">
-                <a:hlinkClick r:id="rId3"/>
+                <a:hlinkClick r:id="rId4"/>
               </a:rPr>
               <a:t>server</a:t>
             </a:r>
@@ -6639,7 +7960,7 @@
         </p:spPr>
         <p:txBody>
           <a:bodyPr>
-            <a:normAutofit lnSpcReduction="10000"/>
+            <a:normAutofit fontScale="92500" lnSpcReduction="20000"/>
           </a:bodyPr>
           <a:lstStyle/>
           <a:p>
@@ -6669,19 +7990,19 @@
             <a:pPr lvl="1"/>
             <a:r>
               <a:rPr lang="en-HK" altLang="zh-CN" dirty="0">
-                <a:hlinkClick r:id="rId2"/>
+                <a:hlinkClick r:id="rId3"/>
               </a:rPr>
               <a:t>https://man7.org/</a:t>
             </a:r>
             <a:r>
               <a:rPr lang="en-HK" altLang="zh-CN" dirty="0" err="1">
-                <a:hlinkClick r:id="rId2"/>
+                <a:hlinkClick r:id="rId3"/>
               </a:rPr>
               <a:t>linux</a:t>
             </a:r>
             <a:r>
               <a:rPr lang="en-HK" altLang="zh-CN" dirty="0">
-                <a:hlinkClick r:id="rId2"/>
+                <a:hlinkClick r:id="rId3"/>
               </a:rPr>
               <a:t>/man-pages/man2/select.2.html</a:t>
             </a:r>
@@ -6713,7 +8034,7 @@
             <a:pPr lvl="1"/>
             <a:r>
               <a:rPr lang="en-US" altLang="zh-CN" dirty="0">
-                <a:hlinkClick r:id="rId3"/>
+                <a:hlinkClick r:id="rId4"/>
               </a:rPr>
               <a:t>https://github.com/henryhxu/CSCI4430/tree/2025_spring/tutorial/T04/select_example</a:t>
             </a:r>
@@ -6786,6 +8107,20 @@
             <a:r>
               <a:rPr lang="en-US" altLang="zh-CN" sz="2800" dirty="0"/>
               <a:t>select</a:t>
+            </a:r>
+          </a:p>
+          <a:p>
+            <a:r>
+              <a:rPr lang="en-US" dirty="0"/>
+              <a:t>You can use </a:t>
+            </a:r>
+            <a:r>
+              <a:rPr lang="en-US" b="1" dirty="0"/>
+              <a:t>ChatGPT</a:t>
+            </a:r>
+            <a:r>
+              <a:rPr lang="en-US" dirty="0"/>
+              <a:t> for understanding the select programming!</a:t>
             </a:r>
             <a:endParaRPr lang="en-HK" dirty="0"/>
           </a:p>
@@ -8072,7 +9407,7 @@
           <p:nvPr/>
         </p:nvPicPr>
         <p:blipFill>
-          <a:blip r:embed="rId2"/>
+          <a:blip r:embed="rId3"/>
           <a:stretch>
             <a:fillRect/>
           </a:stretch>
@@ -8216,7 +9551,7 @@
           <p:nvPr/>
         </p:nvPicPr>
         <p:blipFill rotWithShape="1">
-          <a:blip r:embed="rId2"/>
+          <a:blip r:embed="rId3"/>
           <a:srcRect b="53481"/>
           <a:stretch/>
         </p:blipFill>
@@ -8590,7 +9925,7 @@
           <p:nvPr/>
         </p:nvPicPr>
         <p:blipFill>
-          <a:blip r:embed="rId2"/>
+          <a:blip r:embed="rId3"/>
           <a:stretch>
             <a:fillRect/>
           </a:stretch>

</xml_diff>